<commit_message>
ppt & dokumentáció frissítése
</commit_message>
<xml_diff>
--- a/dokumentumok/Prezentáció_NagyLevedSamuel_TothTamas.pptx
+++ b/dokumentumok/Prezentáció_NagyLevedSamuel_TothTamas.pptx
@@ -274,7 +274,7 @@
       <p15:sldGuideLst xmlns:p15="http://schemas.microsoft.com/office/powerpoint/2012/main"/>
     </p:ext>
     <p:ext uri="GoogleSlidesCustomDataVersion2">
-      <go:slidesCustomData xmlns="" xmlns:mc="http://schemas.openxmlformats.org/markup-compatibility/2006" xmlns:mv="urn:schemas-microsoft-com:mac:vml" xmlns:c="http://schemas.openxmlformats.org/drawingml/2006/chart" xmlns:dgm="http://schemas.openxmlformats.org/drawingml/2006/diagram" xmlns:o="urn:schemas-microsoft-com:office:office" xmlns:v="urn:schemas-microsoft-com:vml" xmlns:pvml="urn:schemas-microsoft-com:office:powerpoint" xmlns:com="http://schemas.openxmlformats.org/drawingml/2006/compatibility" xmlns:p14="http://schemas.microsoft.com/office/powerpoint/2010/main" xmlns:p15="http://schemas.microsoft.com/office/powerpoint/2012/main" xmlns:ahyp="http://schemas.microsoft.com/office/drawing/2018/hyperlinkcolor" xmlns:go="http://customooxmlschemas.google.com/" r:id="rId24" roundtripDataSignature="AMtx7mj67VHAuCHlscAUacmt/Mbt/wFFlA=="/>
+      <go:slidesCustomData xmlns:go="http://customooxmlschemas.google.com/" xmlns:ahyp="http://schemas.microsoft.com/office/drawing/2018/hyperlinkcolor" xmlns:p15="http://schemas.microsoft.com/office/powerpoint/2012/main" xmlns:p14="http://schemas.microsoft.com/office/powerpoint/2010/main" xmlns:com="http://schemas.openxmlformats.org/drawingml/2006/compatibility" xmlns:pvml="urn:schemas-microsoft-com:office:powerpoint" xmlns:v="urn:schemas-microsoft-com:vml" xmlns:o="urn:schemas-microsoft-com:office:office" xmlns:dgm="http://schemas.openxmlformats.org/drawingml/2006/diagram" xmlns:c="http://schemas.openxmlformats.org/drawingml/2006/chart" xmlns:mv="urn:schemas-microsoft-com:mac:vml" xmlns:mc="http://schemas.openxmlformats.org/markup-compatibility/2006" xmlns="" r:id="rId24" roundtripDataSignature="AMtx7mj67VHAuCHlscAUacmt/Mbt/wFFlA=="/>
     </p:ext>
   </p:extLst>
 </p:presentation>
@@ -3744,7 +3744,7 @@
                 <a:cs typeface="Arial"/>
                 <a:sym typeface="Arial"/>
               </a:rPr>
-              <a:t>A frontendünk </a:t>
+              <a:t>A frontendünk, mint említettem </a:t>
             </a:r>
             <a:r>
               <a:rPr lang="hu-HU" sz="1100" b="0" i="0" u="none" strike="noStrike" cap="none" dirty="0" err="1">
@@ -3844,33 +3844,7 @@
                 <a:cs typeface="Arial"/>
                 <a:sym typeface="Arial"/>
               </a:rPr>
-              <a:t>A </a:t>
-            </a:r>
-            <a:r>
-              <a:rPr lang="hu-HU" sz="1100" b="0" i="0" u="none" strike="noStrike" cap="none" dirty="0" err="1">
-                <a:solidFill>
-                  <a:srgbClr val="000000"/>
-                </a:solidFill>
-                <a:effectLst/>
-                <a:latin typeface="Arial"/>
-                <a:ea typeface="Arial"/>
-                <a:cs typeface="Arial"/>
-                <a:sym typeface="Arial"/>
-              </a:rPr>
-              <a:t>dashboard</a:t>
-            </a:r>
-            <a:r>
-              <a:rPr lang="hu-HU" sz="1100" b="0" i="0" u="none" strike="noStrike" cap="none" dirty="0">
-                <a:solidFill>
-                  <a:srgbClr val="000000"/>
-                </a:solidFill>
-                <a:effectLst/>
-                <a:latin typeface="Arial"/>
-                <a:ea typeface="Arial"/>
-                <a:cs typeface="Arial"/>
-                <a:sym typeface="Arial"/>
-              </a:rPr>
-              <a:t> szerepkör szerint jelenik meg, így a diák, tanár és </a:t>
+              <a:t>Az Irányítópult szerepkör szerint jelenik meg, így a diák, tanár és </a:t>
             </a:r>
             <a:r>
               <a:rPr lang="hu-HU" sz="1100" b="0" i="0" u="none" strike="noStrike" cap="none" dirty="0" err="1">
@@ -19563,7 +19537,7 @@
         </p:nvSpPr>
         <p:spPr>
           <a:xfrm rot="5400000">
-            <a:off x="-1468870" y="1124578"/>
+            <a:off x="-1978955" y="1097934"/>
             <a:ext cx="3492600" cy="5292900"/>
           </a:xfrm>
           <a:prstGeom prst="ellipse">
@@ -19668,7 +19642,7 @@
         </p:nvSpPr>
         <p:spPr>
           <a:xfrm>
-            <a:off x="872762" y="2472571"/>
+            <a:off x="2413795" y="2660051"/>
             <a:ext cx="6509700" cy="2585283"/>
           </a:xfrm>
           <a:prstGeom prst="rect">
@@ -20004,7 +19978,7 @@
         </p:blipFill>
         <p:spPr>
           <a:xfrm>
-            <a:off x="8716345" y="262104"/>
+            <a:off x="9182058" y="169611"/>
             <a:ext cx="2852432" cy="6518778"/>
           </a:xfrm>
           <a:prstGeom prst="rect">

</xml_diff>

<commit_message>
kód és ppt javítás
</commit_message>
<xml_diff>
--- a/dokumentumok/Prezentáció_NagyLevedSamuel_TothTamas.pptx
+++ b/dokumentumok/Prezentáció_NagyLevedSamuel_TothTamas.pptx
@@ -274,7 +274,7 @@
       <p15:sldGuideLst xmlns:p15="http://schemas.microsoft.com/office/powerpoint/2012/main"/>
     </p:ext>
     <p:ext uri="GoogleSlidesCustomDataVersion2">
-      <go:slidesCustomData xmlns:go="http://customooxmlschemas.google.com/" xmlns:ahyp="http://schemas.microsoft.com/office/drawing/2018/hyperlinkcolor" xmlns:p15="http://schemas.microsoft.com/office/powerpoint/2012/main" xmlns:p14="http://schemas.microsoft.com/office/powerpoint/2010/main" xmlns:com="http://schemas.openxmlformats.org/drawingml/2006/compatibility" xmlns:pvml="urn:schemas-microsoft-com:office:powerpoint" xmlns:v="urn:schemas-microsoft-com:vml" xmlns:o="urn:schemas-microsoft-com:office:office" xmlns:dgm="http://schemas.openxmlformats.org/drawingml/2006/diagram" xmlns:c="http://schemas.openxmlformats.org/drawingml/2006/chart" xmlns:mv="urn:schemas-microsoft-com:mac:vml" xmlns:mc="http://schemas.openxmlformats.org/markup-compatibility/2006" xmlns="" r:id="rId24" roundtripDataSignature="AMtx7mj67VHAuCHlscAUacmt/Mbt/wFFlA=="/>
+      <go:slidesCustomData xmlns="" xmlns:mc="http://schemas.openxmlformats.org/markup-compatibility/2006" xmlns:mv="urn:schemas-microsoft-com:mac:vml" xmlns:c="http://schemas.openxmlformats.org/drawingml/2006/chart" xmlns:dgm="http://schemas.openxmlformats.org/drawingml/2006/diagram" xmlns:o="urn:schemas-microsoft-com:office:office" xmlns:v="urn:schemas-microsoft-com:vml" xmlns:pvml="urn:schemas-microsoft-com:office:powerpoint" xmlns:com="http://schemas.openxmlformats.org/drawingml/2006/compatibility" xmlns:p14="http://schemas.microsoft.com/office/powerpoint/2010/main" xmlns:p15="http://schemas.microsoft.com/office/powerpoint/2012/main" xmlns:ahyp="http://schemas.microsoft.com/office/drawing/2018/hyperlinkcolor" xmlns:go="http://customooxmlschemas.google.com/" r:id="rId24" roundtripDataSignature="AMtx7mj67VHAuCHlscAUacmt/Mbt/wFFlA=="/>
     </p:ext>
   </p:extLst>
 </p:presentation>
@@ -3785,7 +3785,60 @@
                 <a:cs typeface="Arial"/>
                 <a:sym typeface="Arial"/>
               </a:rPr>
-              <a:t>A modellek és az ORM az adatbázis-műveleteket és relációkat biztosítják.</a:t>
+              <a:t>A modellek és az </a:t>
+            </a:r>
+            <a:r>
+              <a:rPr lang="hu-HU" sz="1100" b="0" i="0" u="none" strike="noStrike" cap="none">
+                <a:solidFill>
+                  <a:srgbClr val="000000"/>
+                </a:solidFill>
+                <a:effectLst/>
+                <a:latin typeface="Arial"/>
+                <a:ea typeface="Arial"/>
+                <a:cs typeface="Arial"/>
+                <a:sym typeface="Arial"/>
+              </a:rPr>
+              <a:t>ORM (azaz </a:t>
+            </a:r>
+            <a:r>
+              <a:rPr lang="hu-HU" sz="1100" b="0" i="0" u="sng" strike="noStrike" cap="none">
+                <a:solidFill>
+                  <a:srgbClr val="000000"/>
+                </a:solidFill>
+                <a:effectLst/>
+                <a:latin typeface="Arial"/>
+                <a:ea typeface="Arial"/>
+                <a:cs typeface="Arial"/>
+                <a:sym typeface="Arial"/>
+                <a:hlinkClick r:id="rId3"/>
+              </a:rPr>
+              <a:t>objektum-relációs leképezés</a:t>
+            </a:r>
+            <a:r>
+              <a:rPr lang="hu-HU" sz="1100" b="0" i="0" u="none" strike="noStrike" cap="none">
+                <a:solidFill>
+                  <a:srgbClr val="000000"/>
+                </a:solidFill>
+                <a:effectLst/>
+                <a:latin typeface="Arial"/>
+                <a:ea typeface="Arial"/>
+                <a:cs typeface="Arial"/>
+                <a:sym typeface="Arial"/>
+              </a:rPr>
+              <a:t> egy olyan programozási technika, amely lehetővé teszi a fejlesztők számára, hogy az objektumorientált kódban használt objektumokat közvetlenül relációs adatbázisokba) az </a:t>
+            </a:r>
+            <a:r>
+              <a:rPr lang="hu-HU" sz="1100" b="0" i="0" u="none" strike="noStrike" cap="none" dirty="0">
+                <a:solidFill>
+                  <a:srgbClr val="000000"/>
+                </a:solidFill>
+                <a:effectLst/>
+                <a:latin typeface="Arial"/>
+                <a:ea typeface="Arial"/>
+                <a:cs typeface="Arial"/>
+                <a:sym typeface="Arial"/>
+              </a:rPr>
+              <a:t>adatbázis-műveleteket és relációkat biztosítják.</a:t>
             </a:r>
             <a:br>
               <a:rPr lang="hu-HU" dirty="0"/>

</xml_diff>

<commit_message>
ppt szöveg video esemény kinézet
</commit_message>
<xml_diff>
--- a/dokumentumok/Prezentáció_NagyLevedSamuel_TothTamas.pptx
+++ b/dokumentumok/Prezentáció_NagyLevedSamuel_TothTamas.pptx
@@ -274,7 +274,7 @@
       <p15:sldGuideLst xmlns:p15="http://schemas.microsoft.com/office/powerpoint/2012/main"/>
     </p:ext>
     <p:ext uri="GoogleSlidesCustomDataVersion2">
-      <go:slidesCustomData xmlns:go="http://customooxmlschemas.google.com/" xmlns:ahyp="http://schemas.microsoft.com/office/drawing/2018/hyperlinkcolor" xmlns:p15="http://schemas.microsoft.com/office/powerpoint/2012/main" xmlns:p14="http://schemas.microsoft.com/office/powerpoint/2010/main" xmlns:com="http://schemas.openxmlformats.org/drawingml/2006/compatibility" xmlns:pvml="urn:schemas-microsoft-com:office:powerpoint" xmlns:v="urn:schemas-microsoft-com:vml" xmlns:o="urn:schemas-microsoft-com:office:office" xmlns:dgm="http://schemas.openxmlformats.org/drawingml/2006/diagram" xmlns:c="http://schemas.openxmlformats.org/drawingml/2006/chart" xmlns:mv="urn:schemas-microsoft-com:mac:vml" xmlns:mc="http://schemas.openxmlformats.org/markup-compatibility/2006" xmlns="" r:id="rId24" roundtripDataSignature="AMtx7mj67VHAuCHlscAUacmt/Mbt/wFFlA=="/>
+      <go:slidesCustomData xmlns="" xmlns:mc="http://schemas.openxmlformats.org/markup-compatibility/2006" xmlns:mv="urn:schemas-microsoft-com:mac:vml" xmlns:c="http://schemas.openxmlformats.org/drawingml/2006/chart" xmlns:dgm="http://schemas.openxmlformats.org/drawingml/2006/diagram" xmlns:o="urn:schemas-microsoft-com:office:office" xmlns:v="urn:schemas-microsoft-com:vml" xmlns:pvml="urn:schemas-microsoft-com:office:powerpoint" xmlns:com="http://schemas.openxmlformats.org/drawingml/2006/compatibility" xmlns:p14="http://schemas.microsoft.com/office/powerpoint/2010/main" xmlns:p15="http://schemas.microsoft.com/office/powerpoint/2012/main" xmlns:ahyp="http://schemas.microsoft.com/office/drawing/2018/hyperlinkcolor" xmlns:go="http://customooxmlschemas.google.com/" r:id="rId24" roundtripDataSignature="AMtx7mj67VHAuCHlscAUacmt/Mbt/wFFlA=="/>
     </p:ext>
   </p:extLst>
 </p:presentation>
@@ -4318,23 +4318,10 @@
                 <a:cs typeface="Arial"/>
                 <a:sym typeface="Arial"/>
               </a:rPr>
-              <a:t>A modellek és az </a:t>
-            </a:r>
-            <a:r>
-              <a:rPr lang="hu-HU" sz="1100" b="0" i="0" u="none" strike="noStrike" cap="none">
-                <a:solidFill>
-                  <a:srgbClr val="000000"/>
-                </a:solidFill>
-                <a:effectLst/>
-                <a:latin typeface="Arial"/>
-                <a:ea typeface="Arial"/>
-                <a:cs typeface="Arial"/>
-                <a:sym typeface="Arial"/>
-              </a:rPr>
-              <a:t>ORM (azaz </a:t>
-            </a:r>
-            <a:r>
-              <a:rPr lang="hu-HU" sz="1100" b="0" i="0" u="sng" strike="noStrike" cap="none">
+              <a:t>A modellek és az ORM (azaz </a:t>
+            </a:r>
+            <a:r>
+              <a:rPr lang="hu-HU" sz="1100" b="0" i="0" u="sng" strike="noStrike" cap="none" dirty="0">
                 <a:solidFill>
                   <a:srgbClr val="000000"/>
                 </a:solidFill>
@@ -4348,7 +4335,7 @@
               <a:t>objektum-relációs leképezés</a:t>
             </a:r>
             <a:r>
-              <a:rPr lang="hu-HU" sz="1100" b="0" i="0" u="none" strike="noStrike" cap="none">
+              <a:rPr lang="hu-HU" sz="1100" b="0" i="0" u="none" strike="noStrike" cap="none" dirty="0">
                 <a:solidFill>
                   <a:srgbClr val="000000"/>
                 </a:solidFill>
@@ -4358,8 +4345,11 @@
                 <a:cs typeface="Arial"/>
                 <a:sym typeface="Arial"/>
               </a:rPr>
-              <a:t> egy olyan programozási technika, amely lehetővé teszi a fejlesztők számára, hogy az objektumorientált kódban használt objektumokat közvetlenül relációs adatbázisokba) az </a:t>
-            </a:r>
+              <a:t> egy olyan programozási technika, amely lehetővé teszi a fejlesztők számára), az adatbázis-műveleteket és relációkat biztosítják.</a:t>
+            </a:r>
+            <a:br>
+              <a:rPr lang="hu-HU" dirty="0"/>
+            </a:br>
             <a:r>
               <a:rPr lang="hu-HU" sz="1100" b="0" i="0" u="none" strike="noStrike" cap="none" dirty="0">
                 <a:solidFill>
@@ -4371,13 +4361,10 @@
                 <a:cs typeface="Arial"/>
                 <a:sym typeface="Arial"/>
               </a:rPr>
-              <a:t>adatbázis-műveleteket és relációkat biztosítják.</a:t>
-            </a:r>
-            <a:br>
-              <a:rPr lang="hu-HU" dirty="0"/>
-            </a:br>
-            <a:r>
-              <a:rPr lang="hu-HU" sz="1100" b="0" i="0" u="none" strike="noStrike" cap="none" dirty="0">
+              <a:t>A </a:t>
+            </a:r>
+            <a:r>
+              <a:rPr lang="hu-HU" sz="1100" b="0" i="0" u="none" strike="noStrike" cap="none" dirty="0" err="1">
                 <a:solidFill>
                   <a:srgbClr val="000000"/>
                 </a:solidFill>
@@ -4387,10 +4374,10 @@
                 <a:cs typeface="Arial"/>
                 <a:sym typeface="Arial"/>
               </a:rPr>
-              <a:t>A </a:t>
-            </a:r>
-            <a:r>
-              <a:rPr lang="hu-HU" sz="1100" b="0" i="0" u="none" strike="noStrike" cap="none" dirty="0" err="1">
+              <a:t>middleware</a:t>
+            </a:r>
+            <a:r>
+              <a:rPr lang="hu-HU" sz="1100" b="0" i="0" u="none" strike="noStrike" cap="none" dirty="0">
                 <a:solidFill>
                   <a:srgbClr val="000000"/>
                 </a:solidFill>
@@ -4400,10 +4387,10 @@
                 <a:cs typeface="Arial"/>
                 <a:sym typeface="Arial"/>
               </a:rPr>
-              <a:t>middleware</a:t>
-            </a:r>
-            <a:r>
-              <a:rPr lang="hu-HU" sz="1100" b="0" i="0" u="none" strike="noStrike" cap="none" dirty="0">
+              <a:t> és az </a:t>
+            </a:r>
+            <a:r>
+              <a:rPr lang="hu-HU" sz="1100" b="0" i="0" u="none" strike="noStrike" cap="none" dirty="0" err="1">
                 <a:solidFill>
                   <a:srgbClr val="000000"/>
                 </a:solidFill>
@@ -4413,10 +4400,10 @@
                 <a:cs typeface="Arial"/>
                 <a:sym typeface="Arial"/>
               </a:rPr>
-              <a:t> és az </a:t>
-            </a:r>
-            <a:r>
-              <a:rPr lang="hu-HU" sz="1100" b="0" i="0" u="none" strike="noStrike" cap="none" dirty="0" err="1">
+              <a:t>autentikációs</a:t>
+            </a:r>
+            <a:r>
+              <a:rPr lang="hu-HU" sz="1100" b="0" i="0" u="none" strike="noStrike" cap="none" dirty="0">
                 <a:solidFill>
                   <a:srgbClr val="000000"/>
                 </a:solidFill>
@@ -4426,8 +4413,11 @@
                 <a:cs typeface="Arial"/>
                 <a:sym typeface="Arial"/>
               </a:rPr>
-              <a:t>autentikációs</a:t>
-            </a:r>
+              <a:t> réteg a biztonságos, szerepköralapú hozzáférést adja.</a:t>
+            </a:r>
+            <a:br>
+              <a:rPr lang="hu-HU" dirty="0"/>
+            </a:br>
             <a:r>
               <a:rPr lang="hu-HU" sz="1100" b="0" i="0" u="none" strike="noStrike" cap="none" dirty="0">
                 <a:solidFill>
@@ -4439,11 +4429,88 @@
                 <a:cs typeface="Arial"/>
                 <a:sym typeface="Arial"/>
               </a:rPr>
-              <a:t> réteg a biztonságos, szerepköralapú hozzáférést adja.</a:t>
-            </a:r>
-            <a:br>
+              <a:t>Ez a struktúra jól skálázható, átlátható és könnyen tesztelhető.</a:t>
+            </a:r>
+          </a:p>
+          <a:p>
+            <a:pPr marL="0" lvl="0" indent="0" algn="l" rtl="0">
+              <a:spcBef>
+                <a:spcPts val="0"/>
+              </a:spcBef>
+              <a:spcAft>
+                <a:spcPts val="0"/>
+              </a:spcAft>
+              <a:buNone/>
+            </a:pPr>
+            <a:r>
+              <a:rPr lang="hu-HU" sz="1100" b="0" i="0" u="none" strike="noStrike" cap="none" dirty="0">
+                <a:solidFill>
+                  <a:srgbClr val="000000"/>
+                </a:solidFill>
+                <a:effectLst/>
+                <a:latin typeface="Arial"/>
+                <a:cs typeface="Arial"/>
+                <a:sym typeface="Arial"/>
+              </a:rPr>
+              <a:t>#######</a:t>
+            </a:r>
+          </a:p>
+          <a:p>
+            <a:pPr marL="0" lvl="0" indent="0" algn="l" rtl="0">
+              <a:spcBef>
+                <a:spcPts val="0"/>
+              </a:spcBef>
+              <a:spcAft>
+                <a:spcPts val="0"/>
+              </a:spcAft>
+              <a:buNone/>
+            </a:pPr>
+            <a:r>
               <a:rPr lang="hu-HU" dirty="0"/>
-            </a:br>
+              <a:t>A backendünk réteges felépítésű, ezért átlátható, jól bővíthető és könnyen karbantartható.</a:t>
+            </a:r>
+          </a:p>
+          <a:p>
+            <a:pPr marL="0" lvl="0" indent="0" algn="l" rtl="0">
+              <a:spcBef>
+                <a:spcPts val="0"/>
+              </a:spcBef>
+              <a:spcAft>
+                <a:spcPts val="0"/>
+              </a:spcAft>
+              <a:buNone/>
+            </a:pPr>
+            <a:r>
+              <a:rPr lang="hu-HU" dirty="0"/>
+              <a:t>A </a:t>
+            </a:r>
+            <a:r>
+              <a:rPr lang="hu-HU" dirty="0" err="1"/>
+              <a:t>routing</a:t>
+            </a:r>
+            <a:r>
+              <a:rPr lang="hu-HU" dirty="0"/>
+              <a:t> réteg a beérkező kéréseket a megfelelő </a:t>
+            </a:r>
+            <a:r>
+              <a:rPr lang="hu-HU" dirty="0" err="1"/>
+              <a:t>controllerhez</a:t>
+            </a:r>
+            <a:r>
+              <a:rPr lang="hu-HU" dirty="0"/>
+              <a:t> irányítja.</a:t>
+            </a:r>
+          </a:p>
+          <a:p>
+            <a:pPr marL="0" lvl="0" indent="0" algn="l" rtl="0">
+              <a:spcBef>
+                <a:spcPts val="0"/>
+              </a:spcBef>
+              <a:spcAft>
+                <a:spcPts val="0"/>
+              </a:spcAft>
+              <a:buNone/>
+            </a:pPr>
             <a:r>
               <a:rPr lang="hu-HU" sz="1100" b="0" i="0" u="none" strike="noStrike" cap="none" dirty="0">
                 <a:solidFill>
@@ -4455,7 +4522,94 @@
                 <a:cs typeface="Arial"/>
                 <a:sym typeface="Arial"/>
               </a:rPr>
-              <a:t>Ez a struktúra jól skálázható, átlátható és könnyen tesztelhető.</a:t>
+              <a:t>A </a:t>
+            </a:r>
+            <a:r>
+              <a:rPr lang="hu-HU" sz="1100" b="0" i="0" u="none" strike="noStrike" cap="none" dirty="0" err="1">
+                <a:solidFill>
+                  <a:srgbClr val="000000"/>
+                </a:solidFill>
+                <a:effectLst/>
+                <a:latin typeface="Arial"/>
+                <a:ea typeface="Arial"/>
+                <a:cs typeface="Arial"/>
+                <a:sym typeface="Arial"/>
+              </a:rPr>
+              <a:t>controllerek</a:t>
+            </a:r>
+            <a:r>
+              <a:rPr lang="hu-HU" sz="1100" b="0" i="0" u="none" strike="noStrike" cap="none" dirty="0">
+                <a:solidFill>
+                  <a:srgbClr val="000000"/>
+                </a:solidFill>
+                <a:effectLst/>
+                <a:latin typeface="Arial"/>
+                <a:ea typeface="Arial"/>
+                <a:cs typeface="Arial"/>
+                <a:sym typeface="Arial"/>
+              </a:rPr>
+              <a:t> végzik a validációt és a jogosultság-ellenőrzést, majd a rendszer működési szabályai szerint feldolgozzák a kéréseket.</a:t>
+            </a:r>
+          </a:p>
+          <a:p>
+            <a:pPr marL="0" lvl="0" indent="0" algn="l" rtl="0">
+              <a:spcBef>
+                <a:spcPts val="0"/>
+              </a:spcBef>
+              <a:spcAft>
+                <a:spcPts val="0"/>
+              </a:spcAft>
+              <a:buNone/>
+            </a:pPr>
+            <a:r>
+              <a:rPr lang="hu-HU" dirty="0"/>
+              <a:t>Az adatkezelést a modellek és az ORM biztosítja, ami egyszerűbbé teszi az adatbázis-műveletek és kapcsolatok kezelését.</a:t>
+            </a:r>
+          </a:p>
+          <a:p>
+            <a:pPr marL="0" lvl="0" indent="0" algn="l" rtl="0">
+              <a:spcBef>
+                <a:spcPts val="0"/>
+              </a:spcBef>
+              <a:spcAft>
+                <a:spcPts val="0"/>
+              </a:spcAft>
+              <a:buNone/>
+            </a:pPr>
+            <a:r>
+              <a:rPr lang="hu-HU" dirty="0"/>
+              <a:t>A </a:t>
+            </a:r>
+            <a:r>
+              <a:rPr lang="hu-HU" dirty="0" err="1"/>
+              <a:t>middleware</a:t>
+            </a:r>
+            <a:r>
+              <a:rPr lang="hu-HU" dirty="0"/>
+              <a:t> és az </a:t>
+            </a:r>
+            <a:r>
+              <a:rPr lang="hu-HU" dirty="0" err="1"/>
+              <a:t>autentikációs</a:t>
+            </a:r>
+            <a:r>
+              <a:rPr lang="hu-HU" dirty="0"/>
+              <a:t> réteg a kérések védelméről és a biztonságos hozzáférésről gondoskodik.</a:t>
+            </a:r>
+          </a:p>
+          <a:p>
+            <a:pPr marL="0" lvl="0" indent="0" algn="l" rtl="0">
+              <a:spcBef>
+                <a:spcPts val="0"/>
+              </a:spcBef>
+              <a:spcAft>
+                <a:spcPts val="0"/>
+              </a:spcAft>
+              <a:buNone/>
+            </a:pPr>
+            <a:r>
+              <a:rPr lang="hu-HU" dirty="0"/>
+              <a:t>Ez az architektúra jól skálázható, stabil alapot ad a fejlesztéshez, és támogatja a hatékony tesztelést is.</a:t>
             </a:r>
             <a:endParaRPr dirty="0"/>
           </a:p>
@@ -5116,6 +5270,152 @@
                 <a:sym typeface="Arial"/>
               </a:rPr>
               <a:t> jogosultsághoz kötöttek, a regisztrációt pedig email-verifikáció védi.</a:t>
+            </a:r>
+          </a:p>
+          <a:p>
+            <a:pPr marL="0" lvl="0" indent="0" algn="l" rtl="0">
+              <a:spcBef>
+                <a:spcPts val="0"/>
+              </a:spcBef>
+              <a:spcAft>
+                <a:spcPts val="0"/>
+              </a:spcAft>
+              <a:buNone/>
+            </a:pPr>
+            <a:r>
+              <a:rPr lang="hu-HU" sz="1100" b="0" i="0" u="none" strike="noStrike" cap="none" dirty="0">
+                <a:solidFill>
+                  <a:srgbClr val="000000"/>
+                </a:solidFill>
+                <a:effectLst/>
+                <a:latin typeface="Arial"/>
+                <a:ea typeface="Arial"/>
+                <a:cs typeface="Arial"/>
+                <a:sym typeface="Arial"/>
+              </a:rPr>
+              <a:t>###########</a:t>
+            </a:r>
+          </a:p>
+          <a:p>
+            <a:pPr marL="0" lvl="0" indent="0" algn="l" rtl="0">
+              <a:spcBef>
+                <a:spcPts val="0"/>
+              </a:spcBef>
+              <a:spcAft>
+                <a:spcPts val="0"/>
+              </a:spcAft>
+              <a:buNone/>
+            </a:pPr>
+            <a:r>
+              <a:rPr lang="hu-HU" sz="1100" b="0" i="0" u="none" strike="noStrike" cap="none" dirty="0">
+                <a:solidFill>
+                  <a:srgbClr val="000000"/>
+                </a:solidFill>
+                <a:effectLst/>
+                <a:latin typeface="Arial"/>
+                <a:ea typeface="Arial"/>
+                <a:cs typeface="Arial"/>
+                <a:sym typeface="Arial"/>
+              </a:rPr>
+              <a:t>A diákok az eseményekben vesznek részt: jelentkezhetnek, visszajelzést adhatnak, szavazhatnak és hozzászólhatnak.</a:t>
+            </a:r>
+          </a:p>
+          <a:p>
+            <a:pPr marL="0" lvl="0" indent="0" algn="l" rtl="0">
+              <a:spcBef>
+                <a:spcPts val="0"/>
+              </a:spcBef>
+              <a:spcAft>
+                <a:spcPts val="0"/>
+              </a:spcAft>
+              <a:buNone/>
+            </a:pPr>
+            <a:r>
+              <a:rPr lang="hu-HU" sz="1100" b="0" i="0" u="none" strike="noStrike" cap="none" dirty="0">
+                <a:solidFill>
+                  <a:srgbClr val="000000"/>
+                </a:solidFill>
+                <a:effectLst/>
+                <a:latin typeface="Arial"/>
+                <a:ea typeface="Arial"/>
+                <a:cs typeface="Arial"/>
+                <a:sym typeface="Arial"/>
+              </a:rPr>
+              <a:t>A tanárok szervezői jogosultságot kapnak: eseményeket hoznak létre, kezelik a szavazásokat és irányítják az osztályszintű folyamatokat.</a:t>
+            </a:r>
+          </a:p>
+          <a:p>
+            <a:pPr marL="0" lvl="0" indent="0" algn="l" rtl="0">
+              <a:spcBef>
+                <a:spcPts val="0"/>
+              </a:spcBef>
+              <a:spcAft>
+                <a:spcPts val="0"/>
+              </a:spcAft>
+              <a:buNone/>
+            </a:pPr>
+            <a:r>
+              <a:rPr lang="hu-HU" sz="1100" b="0" i="0" u="none" strike="noStrike" cap="none" dirty="0">
+                <a:solidFill>
+                  <a:srgbClr val="000000"/>
+                </a:solidFill>
+                <a:effectLst/>
+                <a:latin typeface="Arial"/>
+                <a:ea typeface="Arial"/>
+                <a:cs typeface="Arial"/>
+                <a:sym typeface="Arial"/>
+              </a:rPr>
+              <a:t>Az </a:t>
+            </a:r>
+            <a:r>
+              <a:rPr lang="hu-HU" sz="1100" b="0" i="0" u="none" strike="noStrike" cap="none" dirty="0" err="1">
+                <a:solidFill>
+                  <a:srgbClr val="000000"/>
+                </a:solidFill>
+                <a:effectLst/>
+                <a:latin typeface="Arial"/>
+                <a:ea typeface="Arial"/>
+                <a:cs typeface="Arial"/>
+                <a:sym typeface="Arial"/>
+              </a:rPr>
+              <a:t>adminok</a:t>
+            </a:r>
+            <a:r>
+              <a:rPr lang="hu-HU" sz="1100" b="0" i="0" u="none" strike="noStrike" cap="none" dirty="0">
+                <a:solidFill>
+                  <a:srgbClr val="000000"/>
+                </a:solidFill>
+                <a:effectLst/>
+                <a:latin typeface="Arial"/>
+                <a:ea typeface="Arial"/>
+                <a:cs typeface="Arial"/>
+                <a:sym typeface="Arial"/>
+              </a:rPr>
+              <a:t> a legmagasabb szintű hozzáféréssel rendelkeznek: intézményi beállításokat, felhasználói szerepköröket és kritikus műveleteket kezelnek.</a:t>
+            </a:r>
+          </a:p>
+          <a:p>
+            <a:pPr marL="0" lvl="0" indent="0" algn="l" rtl="0">
+              <a:spcBef>
+                <a:spcPts val="0"/>
+              </a:spcBef>
+              <a:spcAft>
+                <a:spcPts val="0"/>
+              </a:spcAft>
+              <a:buNone/>
+            </a:pPr>
+            <a:r>
+              <a:rPr lang="hu-HU" sz="1100" b="0" i="0" u="none" strike="noStrike" cap="none" dirty="0">
+                <a:solidFill>
+                  <a:srgbClr val="000000"/>
+                </a:solidFill>
+                <a:effectLst/>
+                <a:latin typeface="Arial"/>
+                <a:ea typeface="Arial"/>
+                <a:cs typeface="Arial"/>
+                <a:sym typeface="Arial"/>
+              </a:rPr>
+              <a:t>A regisztráció és az email-verifikáció biztosítja, hogy minden felhasználó a neki megfelelő szerepkörben, ellenőrzött módon használja a rendszert</a:t>
             </a:r>
           </a:p>
         </p:txBody>

</xml_diff>